<commit_message>
feat: mise à jour P13 présentation + ajout P14 attestation stage
</commit_message>
<xml_diff>
--- a/P13_Realisez_votre_portfolio_de_data_engineer_aymeric_bailleul/_projet/_docs/ABAI_P13_02_presentation_11042026.pptx
+++ b/P13_Realisez_votre_portfolio_de_data_engineer_aymeric_bailleul/_projet/_docs/ABAI_P13_02_presentation_11042026.pptx
@@ -207,7 +207,7 @@
           <a:p>
             <a:fld id="{FB9C8E4F-0DAC-4356-BEA1-595E35DECC8F}" type="datetimeFigureOut">
               <a:rPr lang="fr-FR" smtClean="0"/>
-              <a:t>15/04/2026</a:t>
+              <a:t>20/04/2026</a:t>
             </a:fld>
             <a:endParaRPr lang="fr-FR"/>
           </a:p>
@@ -569,7 +569,7 @@
                 <a:ea typeface="+mn-ea"/>
                 <a:cs typeface="+mn-cs"/>
               </a:rPr>
-              <a:t>-Events, une plateforme d'événements culturels. Nous allons voir comment transformer une preuve de concept en un système réellement déployable, maintenable et économiquement viable ?</a:t>
+              <a:t>-Events, une plateforme d'événements culturels. Nous allons voir comment transformer ce POC en un système réellement déployable, maintenable et économiquement viable ?</a:t>
             </a:r>
           </a:p>
           <a:p>
@@ -1430,7 +1430,7 @@
                 <a:ea typeface="+mn-ea"/>
                 <a:cs typeface="+mn-cs"/>
               </a:rPr>
-              <a:t> RAG sur données culturelles fonctionne - les scores Ragas le confirment quantitativement. Mais un POC n'est pas un produit : pas d'historique conversationnel, zone géographique limitée à l'Occitanie, données statiques, et aucun monitoring en production. C'est exactement ce que le MVP doit résoudre."</a:t>
+              <a:t> RAG sur données culturelles fonctionne - les scores Ragas le confirment quantitativement. Mais un POC n'est pas un produit : pas d'historique conversationnel, zone géographique limitée à l'Occitanie, données statiques, et aucun monitoring. C'est exactement ce que le MVP doit résoudre.</a:t>
             </a:r>
           </a:p>
           <a:p>
@@ -1659,6 +1659,26 @@
               <a:tabLst/>
               <a:defRPr/>
             </a:pPr>
+            <a:endParaRPr lang="fr-FR" dirty="0"/>
+          </a:p>
+          <a:p>
+            <a:pPr marL="0" marR="0" lvl="0" indent="0" algn="l" defTabSz="914400" rtl="0" eaLnBrk="1" fontAlgn="auto" latinLnBrk="0" hangingPunct="1">
+              <a:lnSpc>
+                <a:spcPct val="100000"/>
+              </a:lnSpc>
+              <a:spcBef>
+                <a:spcPts val="0"/>
+              </a:spcBef>
+              <a:spcAft>
+                <a:spcPts val="0"/>
+              </a:spcAft>
+              <a:buClrTx/>
+              <a:buSzTx/>
+              <a:buFontTx/>
+              <a:buNone/>
+              <a:tabLst/>
+              <a:defRPr/>
+            </a:pPr>
             <a:r>
               <a:rPr lang="fr-FR" dirty="0"/>
               <a:t>Process </a:t>
@@ -1676,6 +1696,85 @@
               <a:t>etc</a:t>
             </a:r>
             <a:endParaRPr lang="fr-FR" dirty="0"/>
+          </a:p>
+          <a:p>
+            <a:pPr marL="0" marR="0" lvl="0" indent="0" algn="l" defTabSz="914400" rtl="0" eaLnBrk="1" fontAlgn="auto" latinLnBrk="0" hangingPunct="1">
+              <a:lnSpc>
+                <a:spcPct val="100000"/>
+              </a:lnSpc>
+              <a:spcBef>
+                <a:spcPts val="0"/>
+              </a:spcBef>
+              <a:spcAft>
+                <a:spcPts val="0"/>
+              </a:spcAft>
+              <a:buClrTx/>
+              <a:buSzTx/>
+              <a:buFontTx/>
+              <a:buNone/>
+              <a:tabLst/>
+              <a:defRPr/>
+            </a:pPr>
+            <a:endParaRPr lang="fr-FR" dirty="0"/>
+          </a:p>
+          <a:p>
+            <a:pPr marL="0" marR="0" lvl="0" indent="0" algn="l" defTabSz="914400" rtl="0" eaLnBrk="1" fontAlgn="auto" latinLnBrk="0" hangingPunct="1">
+              <a:lnSpc>
+                <a:spcPct val="100000"/>
+              </a:lnSpc>
+              <a:spcBef>
+                <a:spcPts val="0"/>
+              </a:spcBef>
+              <a:spcAft>
+                <a:spcPts val="0"/>
+              </a:spcAft>
+              <a:buClrTx/>
+              <a:buSzTx/>
+              <a:buFontTx/>
+              <a:buNone/>
+              <a:tabLst/>
+              <a:defRPr/>
+            </a:pPr>
+            <a:r>
+              <a:rPr lang="fr-FR" dirty="0" err="1"/>
+              <a:t>Langfuse</a:t>
+            </a:r>
+            <a:r>
+              <a:rPr lang="fr-FR" dirty="0"/>
+              <a:t> est une plateforme </a:t>
+            </a:r>
+            <a:r>
+              <a:rPr lang="fr-FR" b="1" dirty="0"/>
+              <a:t>open-source d'observabilité</a:t>
+            </a:r>
+            <a:r>
+              <a:rPr lang="fr-FR" dirty="0"/>
+              <a:t> pour applications LLM. Elle permet de </a:t>
+            </a:r>
+            <a:r>
+              <a:rPr lang="fr-FR" b="1" dirty="0"/>
+              <a:t>tracer</a:t>
+            </a:r>
+            <a:r>
+              <a:rPr lang="fr-FR" dirty="0"/>
+              <a:t> les requêtes, gérer les </a:t>
+            </a:r>
+            <a:r>
+              <a:rPr lang="fr-FR" b="1" dirty="0"/>
+              <a:t>prompts</a:t>
+            </a:r>
+            <a:r>
+              <a:rPr lang="fr-FR" dirty="0"/>
+              <a:t>, évaluer les réponses et suivre précisément les </a:t>
+            </a:r>
+            <a:r>
+              <a:rPr lang="fr-FR" b="1" dirty="0"/>
+              <a:t>coûts</a:t>
+            </a:r>
+            <a:r>
+              <a:rPr lang="fr-FR" dirty="0"/>
+              <a:t> et performances.</a:t>
+            </a:r>
           </a:p>
         </p:txBody>
       </p:sp>
@@ -1856,22 +1955,150 @@
                 <a:latin typeface="Segoe UI" panose="020B0502040204020203" pitchFamily="34" charset="0"/>
                 <a:cs typeface="Segoe UI" panose="020B0502040204020203" pitchFamily="34" charset="0"/>
               </a:rPr>
-              <a:t> → RAG </a:t>
-            </a:r>
-            <a:r>
-              <a:rPr lang="fr-FR" dirty="0" err="1">
-                <a:latin typeface="Segoe UI" panose="020B0502040204020203" pitchFamily="34" charset="0"/>
-                <a:cs typeface="Segoe UI" panose="020B0502040204020203" pitchFamily="34" charset="0"/>
-              </a:rPr>
-              <a:t>LangChain</a:t>
-            </a:r>
-            <a:r>
-              <a:rPr lang="fr-FR" dirty="0">
-                <a:latin typeface="Segoe UI" panose="020B0502040204020203" pitchFamily="34" charset="0"/>
-                <a:cs typeface="Segoe UI" panose="020B0502040204020203" pitchFamily="34" charset="0"/>
-              </a:rPr>
-              <a:t> + Redis + Filtrage géo</a:t>
-            </a:r>
+              <a:t> → RAG LangChain + Redis + Filtrage géo :</a:t>
+            </a:r>
+          </a:p>
+          <a:p>
+            <a:pPr marL="457200" lvl="1" indent="0">
+              <a:buFontTx/>
+              <a:buNone/>
+            </a:pPr>
+            <a:r>
+              <a:rPr lang="fr-FR" sz="1200" b="0" i="0" kern="1200" dirty="0">
+                <a:solidFill>
+                  <a:schemeClr val="tx1"/>
+                </a:solidFill>
+                <a:effectLst/>
+                <a:latin typeface="+mn-lt"/>
+                <a:ea typeface="+mn-ea"/>
+                <a:cs typeface="+mn-cs"/>
+              </a:rPr>
+              <a:t>Les événements Open Agenda sont ingérés et vectorisés dans </a:t>
+            </a:r>
+            <a:r>
+              <a:rPr lang="fr-FR" sz="1200" b="1" i="0" kern="1200" dirty="0" err="1">
+                <a:solidFill>
+                  <a:schemeClr val="tx1"/>
+                </a:solidFill>
+                <a:effectLst/>
+                <a:latin typeface="+mn-lt"/>
+                <a:ea typeface="+mn-ea"/>
+                <a:cs typeface="+mn-cs"/>
+              </a:rPr>
+              <a:t>Qdrant</a:t>
+            </a:r>
+            <a:r>
+              <a:rPr lang="fr-FR" sz="1200" b="0" i="0" kern="1200" dirty="0">
+                <a:solidFill>
+                  <a:schemeClr val="tx1"/>
+                </a:solidFill>
+                <a:effectLst/>
+                <a:latin typeface="+mn-lt"/>
+                <a:ea typeface="+mn-ea"/>
+                <a:cs typeface="+mn-cs"/>
+              </a:rPr>
+              <a:t>, puis le pipeline </a:t>
+            </a:r>
+            <a:r>
+              <a:rPr lang="fr-FR" sz="1200" b="1" i="0" kern="1200" dirty="0">
+                <a:solidFill>
+                  <a:schemeClr val="tx1"/>
+                </a:solidFill>
+                <a:effectLst/>
+                <a:latin typeface="+mn-lt"/>
+                <a:ea typeface="+mn-ea"/>
+                <a:cs typeface="+mn-cs"/>
+              </a:rPr>
+              <a:t>LangChain RAG</a:t>
+            </a:r>
+            <a:r>
+              <a:rPr lang="fr-FR" sz="1200" b="0" i="0" kern="1200" dirty="0">
+                <a:solidFill>
+                  <a:schemeClr val="tx1"/>
+                </a:solidFill>
+                <a:effectLst/>
+                <a:latin typeface="+mn-lt"/>
+                <a:ea typeface="+mn-ea"/>
+                <a:cs typeface="+mn-cs"/>
+              </a:rPr>
+              <a:t> interroge ce </a:t>
+            </a:r>
+            <a:r>
+              <a:rPr lang="fr-FR" sz="1200" b="0" i="0" kern="1200" dirty="0" err="1">
+                <a:solidFill>
+                  <a:schemeClr val="tx1"/>
+                </a:solidFill>
+                <a:effectLst/>
+                <a:latin typeface="+mn-lt"/>
+                <a:ea typeface="+mn-ea"/>
+                <a:cs typeface="+mn-cs"/>
+              </a:rPr>
+              <a:t>vectorstore</a:t>
+            </a:r>
+            <a:r>
+              <a:rPr lang="fr-FR" sz="1200" b="0" i="0" kern="1200" dirty="0">
+                <a:solidFill>
+                  <a:schemeClr val="tx1"/>
+                </a:solidFill>
+                <a:effectLst/>
+                <a:latin typeface="+mn-lt"/>
+                <a:ea typeface="+mn-ea"/>
+                <a:cs typeface="+mn-cs"/>
+              </a:rPr>
+              <a:t> en appliquant un </a:t>
+            </a:r>
+            <a:r>
+              <a:rPr lang="fr-FR" sz="1200" b="1" i="0" kern="1200" dirty="0">
+                <a:solidFill>
+                  <a:schemeClr val="tx1"/>
+                </a:solidFill>
+                <a:effectLst/>
+                <a:latin typeface="+mn-lt"/>
+                <a:ea typeface="+mn-ea"/>
+                <a:cs typeface="+mn-cs"/>
+              </a:rPr>
+              <a:t>filtrage géospatial</a:t>
+            </a:r>
+            <a:r>
+              <a:rPr lang="fr-FR" sz="1200" b="0" i="0" kern="1200" dirty="0">
+                <a:solidFill>
+                  <a:schemeClr val="tx1"/>
+                </a:solidFill>
+                <a:effectLst/>
+                <a:latin typeface="+mn-lt"/>
+                <a:ea typeface="+mn-ea"/>
+                <a:cs typeface="+mn-cs"/>
+              </a:rPr>
+              <a:t> à la requête, tandis que </a:t>
+            </a:r>
+            <a:r>
+              <a:rPr lang="fr-FR" sz="1200" b="1" i="0" kern="1200" dirty="0">
+                <a:solidFill>
+                  <a:schemeClr val="tx1"/>
+                </a:solidFill>
+                <a:effectLst/>
+                <a:latin typeface="+mn-lt"/>
+                <a:ea typeface="+mn-ea"/>
+                <a:cs typeface="+mn-cs"/>
+              </a:rPr>
+              <a:t>Redis</a:t>
+            </a:r>
+            <a:r>
+              <a:rPr lang="fr-FR" sz="1200" b="0" i="0" kern="1200" dirty="0">
+                <a:solidFill>
+                  <a:schemeClr val="tx1"/>
+                </a:solidFill>
+                <a:effectLst/>
+                <a:latin typeface="+mn-lt"/>
+                <a:ea typeface="+mn-ea"/>
+                <a:cs typeface="+mn-cs"/>
+              </a:rPr>
+              <a:t> maintient le contexte conversationnel entre chaque échange utilisateur.</a:t>
+            </a:r>
+            <a:endParaRPr lang="fr-FR" dirty="0">
+              <a:latin typeface="Segoe UI" panose="020B0502040204020203" pitchFamily="34" charset="0"/>
+              <a:cs typeface="Segoe UI" panose="020B0502040204020203" pitchFamily="34" charset="0"/>
+            </a:endParaRPr>
           </a:p>
           <a:p>
             <a:pPr marL="171450" lvl="0" indent="-171450">
@@ -1904,14 +2131,21 @@
                 <a:latin typeface="Segoe UI" panose="020B0502040204020203" pitchFamily="34" charset="0"/>
                 <a:cs typeface="Segoe UI" panose="020B0502040204020203" pitchFamily="34" charset="0"/>
               </a:rPr>
-              <a:t> + </a:t>
+              <a:t> + Streamlit (voir </a:t>
             </a:r>
             <a:r>
               <a:rPr lang="fr-FR" dirty="0" err="1">
                 <a:latin typeface="Segoe UI" panose="020B0502040204020203" pitchFamily="34" charset="0"/>
                 <a:cs typeface="Segoe UI" panose="020B0502040204020203" pitchFamily="34" charset="0"/>
               </a:rPr>
-              <a:t>Streamlit</a:t>
+              <a:t>React</a:t>
+            </a:r>
+            <a:r>
+              <a:rPr lang="fr-FR" dirty="0">
+                <a:latin typeface="Segoe UI" panose="020B0502040204020203" pitchFamily="34" charset="0"/>
+                <a:cs typeface="Segoe UI" panose="020B0502040204020203" pitchFamily="34" charset="0"/>
+              </a:rPr>
+              <a:t> par ex)</a:t>
             </a:r>
             <a:endParaRPr lang="fr-FR" b="0" dirty="0">
               <a:latin typeface="Segoe UI" panose="020B0502040204020203" pitchFamily="34" charset="0"/>
@@ -2250,7 +2484,7 @@
                 <a:ea typeface="+mn-ea"/>
                 <a:cs typeface="+mn-cs"/>
               </a:rPr>
-              <a:t> est le choix technique le plus structurant. FAISS est une bibliothèque de recherche vectorielle en mémoire - elle ne supporte pas le filtrage par métadonnées. Or, pour filtrer les événements par localisation géographique à la requête, il nous faut un </a:t>
+              <a:t> est le choix technique le plus structurant. FAISS est une bibliothèque de recherche vectorielle en mémoire - elle ne supporte pas le filtrage par métadonnées. Alors que  pour filtrer les événements par localisation géographique à la requête, il nous faut un </a:t>
             </a:r>
             <a:r>
               <a:rPr lang="fr-FR" sz="1200" b="0" kern="1200" dirty="0" err="1">
@@ -2274,7 +2508,7 @@
                 <a:ea typeface="+mn-ea"/>
                 <a:cs typeface="+mn-cs"/>
               </a:rPr>
-              <a:t> qui stocke les coordonnées GPS comme métadonnées interrogeables comme </a:t>
+              <a:t> qui stocke les coordonnées GPS comme métadonnées interrogeables : </a:t>
             </a:r>
             <a:r>
               <a:rPr lang="fr-FR" sz="1200" b="0" kern="1200" dirty="0" err="1">
@@ -2557,7 +2791,7 @@
                 <a:ea typeface="+mn-ea"/>
                 <a:cs typeface="+mn-cs"/>
               </a:rPr>
-              <a:t>			Stockage de session ultra-rapide avec TTL automatique, indispensable pour la fenêtre de contexte conversationnelle.</a:t>
+              <a:t>			Stockage de session ultra-rapide avec TTL automatique (nettoyage de la session auto = pas de donnée perso stocker = RGPD), indispensable pour la fenêtre de contexte conversationnelle.</a:t>
             </a:r>
           </a:p>
           <a:p>
@@ -2619,7 +2853,7 @@
                 <a:ea typeface="+mn-ea"/>
                 <a:cs typeface="+mn-cs"/>
               </a:rPr>
-              <a:t> natif sur événements récents non indexés, sans dépendance à une API tierce. == Si </a:t>
+              <a:t> sur événements récents non indexés. Sans dépendance à une API tierce. == Si </a:t>
             </a:r>
             <a:r>
               <a:rPr lang="fr-FR" sz="1200" b="0" i="0" kern="1200" dirty="0" err="1">
@@ -2791,7 +3025,7 @@
                 <a:ea typeface="+mn-ea"/>
                 <a:cs typeface="+mn-cs"/>
               </a:rPr>
-              <a:t>Déploiement continu automatique sur chaque merge main, zéro intervention manuelle.</a:t>
+              <a:t>Déploiement continu automatique sur chaque merge, zéro intervention manuelle.</a:t>
             </a:r>
           </a:p>
           <a:p>
@@ -3044,7 +3278,7 @@
                 <a:ea typeface="+mn-ea"/>
                 <a:cs typeface="+mn-cs"/>
               </a:rPr>
-              <a:t>La priorisation Must-Have / Nice-to-Have est essentielle dans ce type de projet. Les 12 fonctionnalités must-have forment le MVP strict — sans elles, le produit n'est pas livrable. Les 7 </a:t>
+              <a:t>La priorisation Must-Have / Nice-to-Have est essentielle. Les 12 fonctionnalités must-have forment le MVP strict — sans elles, le produit n'est pas livrable. Les 7 </a:t>
             </a:r>
             <a:r>
               <a:rPr lang="fr-FR" sz="1200" b="0" kern="1200" dirty="0" err="1">
@@ -3068,7 +3302,7 @@
                 <a:ea typeface="+mn-ea"/>
                 <a:cs typeface="+mn-cs"/>
               </a:rPr>
-              <a:t>-to-have apportent de la valeur, mais ne bloquent pas la livraison. Cette distinction protège le planning des glissements classiques en projet IA, où la tentation d'ajouter des features est permanente</a:t>
+              <a:t>-to-have apportent de la valeur, mais ne bloquent pas la livraison. Cette distinction protège le planning des glissements classiques, où la tentation d'ajouter des features est permanente</a:t>
             </a:r>
           </a:p>
         </p:txBody>
@@ -3831,7 +4065,7 @@
                 <a:ea typeface="+mn-ea"/>
                 <a:cs typeface="+mn-cs"/>
               </a:rPr>
-              <a:t>Coûts LLM à l'échelle → Cache Redis + sampling Ragas 10 %</a:t>
+              <a:t>Coûts Mistral à l'échelle → Cache Redis + sampling Ragas 10 %</a:t>
             </a:r>
             <a:br>
               <a:rPr lang="fr-FR" sz="1200" b="0" i="0" kern="1200" dirty="0">
@@ -4185,7 +4419,7 @@
           <a:noFill/>
           <a:extLst>
             <a:ext uri="{909E8E84-426E-40dd-AFC4-6F175D3DCCD1}">
-              <a14:hiddenFill xmlns:a14="http://schemas.microsoft.com/office/drawing/2010/main" xmlns="">
+              <a14:hiddenFill xmlns="" xmlns:a14="http://schemas.microsoft.com/office/drawing/2010/main">
                 <a:solidFill>
                   <a:srgbClr val="FFFFFF"/>
                 </a:solidFill>
@@ -4245,7 +4479,7 @@
             </a:ln>
             <a:extLst>
               <a:ext uri="{91240B29-F687-4f45-9708-019B960494DF}">
-                <a14:hiddenLine xmlns:a14="http://schemas.microsoft.com/office/drawing/2010/main" xmlns="" w="9525">
+                <a14:hiddenLine xmlns="" xmlns:a14="http://schemas.microsoft.com/office/drawing/2010/main" w="9525">
                   <a:solidFill>
                     <a:srgbClr val="000000"/>
                   </a:solidFill>
@@ -4335,7 +4569,7 @@
             </a:ln>
             <a:extLst>
               <a:ext uri="{91240B29-F687-4f45-9708-019B960494DF}">
-                <a14:hiddenLine xmlns:a14="http://schemas.microsoft.com/office/drawing/2010/main" xmlns="" w="9525">
+                <a14:hiddenLine xmlns="" xmlns:a14="http://schemas.microsoft.com/office/drawing/2010/main" w="9525">
                   <a:solidFill>
                     <a:srgbClr val="000000"/>
                   </a:solidFill>
@@ -4425,7 +4659,7 @@
             </a:ln>
             <a:extLst>
               <a:ext uri="{91240B29-F687-4f45-9708-019B960494DF}">
-                <a14:hiddenLine xmlns:a14="http://schemas.microsoft.com/office/drawing/2010/main" xmlns="" w="9525">
+                <a14:hiddenLine xmlns="" xmlns:a14="http://schemas.microsoft.com/office/drawing/2010/main" w="9525">
                   <a:solidFill>
                     <a:srgbClr val="000000"/>
                   </a:solidFill>
@@ -4459,7 +4693,7 @@
             </a:ln>
             <a:extLst>
               <a:ext uri="{91240B29-F687-4f45-9708-019B960494DF}">
-                <a14:hiddenLine xmlns:a14="http://schemas.microsoft.com/office/drawing/2010/main" xmlns="" w="9525">
+                <a14:hiddenLine xmlns="" xmlns:a14="http://schemas.microsoft.com/office/drawing/2010/main" w="9525">
                   <a:solidFill>
                     <a:srgbClr val="000000"/>
                   </a:solidFill>
@@ -4549,7 +4783,7 @@
             </a:ln>
             <a:extLst>
               <a:ext uri="{91240B29-F687-4f45-9708-019B960494DF}">
-                <a14:hiddenLine xmlns:a14="http://schemas.microsoft.com/office/drawing/2010/main" xmlns="" w="9525">
+                <a14:hiddenLine xmlns="" xmlns:a14="http://schemas.microsoft.com/office/drawing/2010/main" w="9525">
                   <a:solidFill>
                     <a:srgbClr val="000000"/>
                   </a:solidFill>
@@ -4611,7 +4845,7 @@
             </a:ln>
             <a:extLst>
               <a:ext uri="{91240B29-F687-4f45-9708-019B960494DF}">
-                <a14:hiddenLine xmlns:a14="http://schemas.microsoft.com/office/drawing/2010/main" xmlns="" w="9525">
+                <a14:hiddenLine xmlns="" xmlns:a14="http://schemas.microsoft.com/office/drawing/2010/main" w="9525">
                   <a:solidFill>
                     <a:srgbClr val="000000"/>
                   </a:solidFill>
@@ -4673,7 +4907,7 @@
             </a:ln>
             <a:extLst>
               <a:ext uri="{91240B29-F687-4f45-9708-019B960494DF}">
-                <a14:hiddenLine xmlns:a14="http://schemas.microsoft.com/office/drawing/2010/main" xmlns="" w="9525">
+                <a14:hiddenLine xmlns="" xmlns:a14="http://schemas.microsoft.com/office/drawing/2010/main" w="9525">
                   <a:solidFill>
                     <a:srgbClr val="000000"/>
                   </a:solidFill>
@@ -4763,7 +4997,7 @@
             </a:ln>
             <a:extLst>
               <a:ext uri="{91240B29-F687-4f45-9708-019B960494DF}">
-                <a14:hiddenLine xmlns:a14="http://schemas.microsoft.com/office/drawing/2010/main" xmlns="" w="9525">
+                <a14:hiddenLine xmlns="" xmlns:a14="http://schemas.microsoft.com/office/drawing/2010/main" w="9525">
                   <a:solidFill>
                     <a:srgbClr val="000000"/>
                   </a:solidFill>
@@ -4825,7 +5059,7 @@
             </a:ln>
             <a:extLst>
               <a:ext uri="{91240B29-F687-4f45-9708-019B960494DF}">
-                <a14:hiddenLine xmlns:a14="http://schemas.microsoft.com/office/drawing/2010/main" xmlns="" w="9525">
+                <a14:hiddenLine xmlns="" xmlns:a14="http://schemas.microsoft.com/office/drawing/2010/main" w="9525">
                   <a:solidFill>
                     <a:srgbClr val="000000"/>
                   </a:solidFill>
@@ -4887,7 +5121,7 @@
             </a:ln>
             <a:extLst>
               <a:ext uri="{91240B29-F687-4f45-9708-019B960494DF}">
-                <a14:hiddenLine xmlns:a14="http://schemas.microsoft.com/office/drawing/2010/main" xmlns="" w="9525">
+                <a14:hiddenLine xmlns="" xmlns:a14="http://schemas.microsoft.com/office/drawing/2010/main" w="9525">
                   <a:solidFill>
                     <a:srgbClr val="000000"/>
                   </a:solidFill>
@@ -4977,7 +5211,7 @@
             </a:ln>
             <a:extLst>
               <a:ext uri="{91240B29-F687-4f45-9708-019B960494DF}">
-                <a14:hiddenLine xmlns:a14="http://schemas.microsoft.com/office/drawing/2010/main" xmlns="" w="9525">
+                <a14:hiddenLine xmlns="" xmlns:a14="http://schemas.microsoft.com/office/drawing/2010/main" w="9525">
                   <a:solidFill>
                     <a:srgbClr val="000000"/>
                   </a:solidFill>
@@ -5067,7 +5301,7 @@
             </a:ln>
             <a:extLst>
               <a:ext uri="{91240B29-F687-4f45-9708-019B960494DF}">
-                <a14:hiddenLine xmlns:a14="http://schemas.microsoft.com/office/drawing/2010/main" xmlns="" w="9525">
+                <a14:hiddenLine xmlns="" xmlns:a14="http://schemas.microsoft.com/office/drawing/2010/main" w="9525">
                   <a:solidFill>
                     <a:srgbClr val="000000"/>
                   </a:solidFill>
@@ -5129,7 +5363,7 @@
             </a:ln>
             <a:extLst>
               <a:ext uri="{91240B29-F687-4f45-9708-019B960494DF}">
-                <a14:hiddenLine xmlns:a14="http://schemas.microsoft.com/office/drawing/2010/main" xmlns="" w="9525">
+                <a14:hiddenLine xmlns="" xmlns:a14="http://schemas.microsoft.com/office/drawing/2010/main" w="9525">
                   <a:solidFill>
                     <a:srgbClr val="000000"/>
                   </a:solidFill>
@@ -5239,7 +5473,7 @@
             </a:ln>
             <a:extLst>
               <a:ext uri="{91240B29-F687-4f45-9708-019B960494DF}">
-                <a14:hiddenLine xmlns:a14="http://schemas.microsoft.com/office/drawing/2010/main" xmlns="" w="9525">
+                <a14:hiddenLine xmlns="" xmlns:a14="http://schemas.microsoft.com/office/drawing/2010/main" w="9525">
                   <a:solidFill>
                     <a:srgbClr val="000000"/>
                   </a:solidFill>
@@ -5301,7 +5535,7 @@
             </a:ln>
             <a:extLst>
               <a:ext uri="{91240B29-F687-4f45-9708-019B960494DF}">
-                <a14:hiddenLine xmlns:a14="http://schemas.microsoft.com/office/drawing/2010/main" xmlns="" w="9525">
+                <a14:hiddenLine xmlns="" xmlns:a14="http://schemas.microsoft.com/office/drawing/2010/main" w="9525">
                   <a:solidFill>
                     <a:srgbClr val="000000"/>
                   </a:solidFill>
@@ -5391,7 +5625,7 @@
             </a:ln>
             <a:extLst>
               <a:ext uri="{91240B29-F687-4f45-9708-019B960494DF}">
-                <a14:hiddenLine xmlns:a14="http://schemas.microsoft.com/office/drawing/2010/main" xmlns="" w="9525">
+                <a14:hiddenLine xmlns="" xmlns:a14="http://schemas.microsoft.com/office/drawing/2010/main" w="9525">
                   <a:solidFill>
                     <a:srgbClr val="000000"/>
                   </a:solidFill>
@@ -5481,7 +5715,7 @@
             </a:ln>
             <a:extLst>
               <a:ext uri="{91240B29-F687-4f45-9708-019B960494DF}">
-                <a14:hiddenLine xmlns:a14="http://schemas.microsoft.com/office/drawing/2010/main" xmlns="" w="9525">
+                <a14:hiddenLine xmlns="" xmlns:a14="http://schemas.microsoft.com/office/drawing/2010/main" w="9525">
                   <a:solidFill>
                     <a:srgbClr val="000000"/>
                   </a:solidFill>
@@ -5543,7 +5777,7 @@
             </a:ln>
             <a:extLst>
               <a:ext uri="{91240B29-F687-4f45-9708-019B960494DF}">
-                <a14:hiddenLine xmlns:a14="http://schemas.microsoft.com/office/drawing/2010/main" xmlns="" w="9525">
+                <a14:hiddenLine xmlns="" xmlns:a14="http://schemas.microsoft.com/office/drawing/2010/main" w="9525">
                   <a:solidFill>
                     <a:srgbClr val="000000"/>
                   </a:solidFill>
@@ -5633,7 +5867,7 @@
             </a:ln>
             <a:extLst>
               <a:ext uri="{91240B29-F687-4f45-9708-019B960494DF}">
-                <a14:hiddenLine xmlns:a14="http://schemas.microsoft.com/office/drawing/2010/main" xmlns="" w="9525">
+                <a14:hiddenLine xmlns="" xmlns:a14="http://schemas.microsoft.com/office/drawing/2010/main" w="9525">
                   <a:solidFill>
                     <a:srgbClr val="000000"/>
                   </a:solidFill>
@@ -5723,7 +5957,7 @@
             </a:ln>
             <a:extLst>
               <a:ext uri="{91240B29-F687-4f45-9708-019B960494DF}">
-                <a14:hiddenLine xmlns:a14="http://schemas.microsoft.com/office/drawing/2010/main" xmlns="" w="9525">
+                <a14:hiddenLine xmlns="" xmlns:a14="http://schemas.microsoft.com/office/drawing/2010/main" w="9525">
                   <a:solidFill>
                     <a:srgbClr val="000000"/>
                   </a:solidFill>
@@ -5779,7 +6013,7 @@
             </a:ln>
             <a:extLst>
               <a:ext uri="{91240B29-F687-4f45-9708-019B960494DF}">
-                <a14:hiddenLine xmlns:a14="http://schemas.microsoft.com/office/drawing/2010/main" xmlns="" w="9525">
+                <a14:hiddenLine xmlns="" xmlns:a14="http://schemas.microsoft.com/office/drawing/2010/main" w="9525">
                   <a:solidFill>
                     <a:srgbClr val="000000"/>
                   </a:solidFill>
@@ -5869,7 +6103,7 @@
             </a:ln>
             <a:extLst>
               <a:ext uri="{91240B29-F687-4f45-9708-019B960494DF}">
-                <a14:hiddenLine xmlns:a14="http://schemas.microsoft.com/office/drawing/2010/main" xmlns="" w="9525">
+                <a14:hiddenLine xmlns="" xmlns:a14="http://schemas.microsoft.com/office/drawing/2010/main" w="9525">
                   <a:solidFill>
                     <a:srgbClr val="000000"/>
                   </a:solidFill>
@@ -5925,7 +6159,7 @@
             </a:ln>
             <a:extLst>
               <a:ext uri="{91240B29-F687-4f45-9708-019B960494DF}">
-                <a14:hiddenLine xmlns:a14="http://schemas.microsoft.com/office/drawing/2010/main" xmlns="" w="9525">
+                <a14:hiddenLine xmlns="" xmlns:a14="http://schemas.microsoft.com/office/drawing/2010/main" w="9525">
                   <a:solidFill>
                     <a:srgbClr val="000000"/>
                   </a:solidFill>
@@ -6015,7 +6249,7 @@
             </a:ln>
             <a:extLst>
               <a:ext uri="{91240B29-F687-4f45-9708-019B960494DF}">
-                <a14:hiddenLine xmlns:a14="http://schemas.microsoft.com/office/drawing/2010/main" xmlns="" w="9525">
+                <a14:hiddenLine xmlns="" xmlns:a14="http://schemas.microsoft.com/office/drawing/2010/main" w="9525">
                   <a:solidFill>
                     <a:srgbClr val="000000"/>
                   </a:solidFill>
@@ -6083,7 +6317,7 @@
             </a:ln>
             <a:extLst>
               <a:ext uri="{91240B29-F687-4f45-9708-019B960494DF}">
-                <a14:hiddenLine xmlns:a14="http://schemas.microsoft.com/office/drawing/2010/main" xmlns="" w="9525">
+                <a14:hiddenLine xmlns="" xmlns:a14="http://schemas.microsoft.com/office/drawing/2010/main" w="9525">
                   <a:solidFill>
                     <a:srgbClr val="000000"/>
                   </a:solidFill>
@@ -6173,7 +6407,7 @@
             </a:ln>
             <a:extLst>
               <a:ext uri="{91240B29-F687-4f45-9708-019B960494DF}">
-                <a14:hiddenLine xmlns:a14="http://schemas.microsoft.com/office/drawing/2010/main" xmlns="" w="9525">
+                <a14:hiddenLine xmlns="" xmlns:a14="http://schemas.microsoft.com/office/drawing/2010/main" w="9525">
                   <a:solidFill>
                     <a:srgbClr val="000000"/>
                   </a:solidFill>
@@ -6241,7 +6475,7 @@
             </a:ln>
             <a:extLst>
               <a:ext uri="{91240B29-F687-4f45-9708-019B960494DF}">
-                <a14:hiddenLine xmlns:a14="http://schemas.microsoft.com/office/drawing/2010/main" xmlns="" w="9525">
+                <a14:hiddenLine xmlns="" xmlns:a14="http://schemas.microsoft.com/office/drawing/2010/main" w="9525">
                   <a:solidFill>
                     <a:srgbClr val="000000"/>
                   </a:solidFill>
@@ -6331,7 +6565,7 @@
             </a:ln>
             <a:extLst>
               <a:ext uri="{91240B29-F687-4f45-9708-019B960494DF}">
-                <a14:hiddenLine xmlns:a14="http://schemas.microsoft.com/office/drawing/2010/main" xmlns="" w="9525">
+                <a14:hiddenLine xmlns="" xmlns:a14="http://schemas.microsoft.com/office/drawing/2010/main" w="9525">
                   <a:solidFill>
                     <a:srgbClr val="000000"/>
                   </a:solidFill>
@@ -6365,7 +6599,7 @@
             </a:ln>
             <a:extLst>
               <a:ext uri="{91240B29-F687-4f45-9708-019B960494DF}">
-                <a14:hiddenLine xmlns:a14="http://schemas.microsoft.com/office/drawing/2010/main" xmlns="" w="9525">
+                <a14:hiddenLine xmlns="" xmlns:a14="http://schemas.microsoft.com/office/drawing/2010/main" w="9525">
                   <a:solidFill>
                     <a:srgbClr val="000000"/>
                   </a:solidFill>
@@ -6455,7 +6689,7 @@
             </a:ln>
             <a:extLst>
               <a:ext uri="{91240B29-F687-4f45-9708-019B960494DF}">
-                <a14:hiddenLine xmlns:a14="http://schemas.microsoft.com/office/drawing/2010/main" xmlns="" w="9525">
+                <a14:hiddenLine xmlns="" xmlns:a14="http://schemas.microsoft.com/office/drawing/2010/main" w="9525">
                   <a:solidFill>
                     <a:srgbClr val="000000"/>
                   </a:solidFill>
@@ -6517,7 +6751,7 @@
             </a:ln>
             <a:extLst>
               <a:ext uri="{91240B29-F687-4f45-9708-019B960494DF}">
-                <a14:hiddenLine xmlns:a14="http://schemas.microsoft.com/office/drawing/2010/main" xmlns="" w="9525">
+                <a14:hiddenLine xmlns="" xmlns:a14="http://schemas.microsoft.com/office/drawing/2010/main" w="9525">
                   <a:solidFill>
                     <a:srgbClr val="000000"/>
                   </a:solidFill>
@@ -6579,7 +6813,7 @@
             </a:ln>
             <a:extLst>
               <a:ext uri="{91240B29-F687-4f45-9708-019B960494DF}">
-                <a14:hiddenLine xmlns:a14="http://schemas.microsoft.com/office/drawing/2010/main" xmlns="" w="9525">
+                <a14:hiddenLine xmlns="" xmlns:a14="http://schemas.microsoft.com/office/drawing/2010/main" w="9525">
                   <a:solidFill>
                     <a:srgbClr val="000000"/>
                   </a:solidFill>
@@ -6669,7 +6903,7 @@
             </a:ln>
             <a:extLst>
               <a:ext uri="{91240B29-F687-4f45-9708-019B960494DF}">
-                <a14:hiddenLine xmlns:a14="http://schemas.microsoft.com/office/drawing/2010/main" xmlns="" w="9525">
+                <a14:hiddenLine xmlns="" xmlns:a14="http://schemas.microsoft.com/office/drawing/2010/main" w="9525">
                   <a:solidFill>
                     <a:srgbClr val="000000"/>
                   </a:solidFill>
@@ -6737,7 +6971,7 @@
             </a:ln>
             <a:extLst>
               <a:ext uri="{91240B29-F687-4f45-9708-019B960494DF}">
-                <a14:hiddenLine xmlns:a14="http://schemas.microsoft.com/office/drawing/2010/main" xmlns="" w="9525">
+                <a14:hiddenLine xmlns="" xmlns:a14="http://schemas.microsoft.com/office/drawing/2010/main" w="9525">
                   <a:solidFill>
                     <a:srgbClr val="000000"/>
                   </a:solidFill>
@@ -6799,7 +7033,7 @@
             </a:ln>
             <a:extLst>
               <a:ext uri="{91240B29-F687-4f45-9708-019B960494DF}">
-                <a14:hiddenLine xmlns:a14="http://schemas.microsoft.com/office/drawing/2010/main" xmlns="" w="9525">
+                <a14:hiddenLine xmlns="" xmlns:a14="http://schemas.microsoft.com/office/drawing/2010/main" w="9525">
                   <a:solidFill>
                     <a:srgbClr val="000000"/>
                   </a:solidFill>
@@ -6889,7 +7123,7 @@
             </a:ln>
             <a:extLst>
               <a:ext uri="{91240B29-F687-4f45-9708-019B960494DF}">
-                <a14:hiddenLine xmlns:a14="http://schemas.microsoft.com/office/drawing/2010/main" xmlns="" w="9525">
+                <a14:hiddenLine xmlns="" xmlns:a14="http://schemas.microsoft.com/office/drawing/2010/main" w="9525">
                   <a:solidFill>
                     <a:srgbClr val="000000"/>
                   </a:solidFill>
@@ -6951,7 +7185,7 @@
             </a:ln>
             <a:extLst>
               <a:ext uri="{91240B29-F687-4f45-9708-019B960494DF}">
-                <a14:hiddenLine xmlns:a14="http://schemas.microsoft.com/office/drawing/2010/main" xmlns="" w="9525">
+                <a14:hiddenLine xmlns="" xmlns:a14="http://schemas.microsoft.com/office/drawing/2010/main" w="9525">
                   <a:solidFill>
                     <a:srgbClr val="000000"/>
                   </a:solidFill>
@@ -7041,7 +7275,7 @@
             </a:ln>
             <a:extLst>
               <a:ext uri="{91240B29-F687-4f45-9708-019B960494DF}">
-                <a14:hiddenLine xmlns:a14="http://schemas.microsoft.com/office/drawing/2010/main" xmlns="" w="9525">
+                <a14:hiddenLine xmlns="" xmlns:a14="http://schemas.microsoft.com/office/drawing/2010/main" w="9525">
                   <a:solidFill>
                     <a:srgbClr val="000000"/>
                   </a:solidFill>
@@ -7103,7 +7337,7 @@
             </a:ln>
             <a:extLst>
               <a:ext uri="{91240B29-F687-4f45-9708-019B960494DF}">
-                <a14:hiddenLine xmlns:a14="http://schemas.microsoft.com/office/drawing/2010/main" xmlns="" w="9525">
+                <a14:hiddenLine xmlns="" xmlns:a14="http://schemas.microsoft.com/office/drawing/2010/main" w="9525">
                   <a:solidFill>
                     <a:srgbClr val="000000"/>
                   </a:solidFill>
@@ -7193,7 +7427,7 @@
             </a:ln>
             <a:extLst>
               <a:ext uri="{91240B29-F687-4f45-9708-019B960494DF}">
-                <a14:hiddenLine xmlns:a14="http://schemas.microsoft.com/office/drawing/2010/main" xmlns="" w="9525">
+                <a14:hiddenLine xmlns="" xmlns:a14="http://schemas.microsoft.com/office/drawing/2010/main" w="9525">
                   <a:solidFill>
                     <a:srgbClr val="000000"/>
                   </a:solidFill>
@@ -7227,7 +7461,7 @@
             </a:ln>
             <a:extLst>
               <a:ext uri="{91240B29-F687-4f45-9708-019B960494DF}">
-                <a14:hiddenLine xmlns:a14="http://schemas.microsoft.com/office/drawing/2010/main" xmlns="" w="9525">
+                <a14:hiddenLine xmlns="" xmlns:a14="http://schemas.microsoft.com/office/drawing/2010/main" w="9525">
                   <a:solidFill>
                     <a:srgbClr val="000000"/>
                   </a:solidFill>
@@ -7292,7 +7526,7 @@
             </a:ln>
             <a:extLst>
               <a:ext uri="{91240B29-F687-4f45-9708-019B960494DF}">
-                <a14:hiddenLine xmlns:a14="http://schemas.microsoft.com/office/drawing/2010/main" xmlns="" w="9525">
+                <a14:hiddenLine xmlns="" xmlns:a14="http://schemas.microsoft.com/office/drawing/2010/main" w="9525">
                   <a:solidFill>
                     <a:srgbClr val="000000"/>
                   </a:solidFill>
@@ -7382,7 +7616,7 @@
             </a:ln>
             <a:extLst>
               <a:ext uri="{91240B29-F687-4f45-9708-019B960494DF}">
-                <a14:hiddenLine xmlns:a14="http://schemas.microsoft.com/office/drawing/2010/main" xmlns="" w="9525">
+                <a14:hiddenLine xmlns="" xmlns:a14="http://schemas.microsoft.com/office/drawing/2010/main" w="9525">
                   <a:solidFill>
                     <a:srgbClr val="000000"/>
                   </a:solidFill>
@@ -7444,7 +7678,7 @@
             </a:ln>
             <a:extLst>
               <a:ext uri="{91240B29-F687-4f45-9708-019B960494DF}">
-                <a14:hiddenLine xmlns:a14="http://schemas.microsoft.com/office/drawing/2010/main" xmlns="" w="9525">
+                <a14:hiddenLine xmlns="" xmlns:a14="http://schemas.microsoft.com/office/drawing/2010/main" w="9525">
                   <a:solidFill>
                     <a:srgbClr val="000000"/>
                   </a:solidFill>
@@ -7534,7 +7768,7 @@
             </a:ln>
             <a:extLst>
               <a:ext uri="{91240B29-F687-4f45-9708-019B960494DF}">
-                <a14:hiddenLine xmlns:a14="http://schemas.microsoft.com/office/drawing/2010/main" xmlns="" w="9525">
+                <a14:hiddenLine xmlns="" xmlns:a14="http://schemas.microsoft.com/office/drawing/2010/main" w="9525">
                   <a:solidFill>
                     <a:srgbClr val="000000"/>
                   </a:solidFill>
@@ -7624,7 +7858,7 @@
             </a:ln>
             <a:extLst>
               <a:ext uri="{91240B29-F687-4f45-9708-019B960494DF}">
-                <a14:hiddenLine xmlns:a14="http://schemas.microsoft.com/office/drawing/2010/main" xmlns="" w="9525">
+                <a14:hiddenLine xmlns="" xmlns:a14="http://schemas.microsoft.com/office/drawing/2010/main" w="9525">
                   <a:solidFill>
                     <a:srgbClr val="000000"/>
                   </a:solidFill>
@@ -7689,7 +7923,7 @@
             </a:ln>
             <a:extLst>
               <a:ext uri="{91240B29-F687-4f45-9708-019B960494DF}">
-                <a14:hiddenLine xmlns:a14="http://schemas.microsoft.com/office/drawing/2010/main" xmlns="" w="9525">
+                <a14:hiddenLine xmlns="" xmlns:a14="http://schemas.microsoft.com/office/drawing/2010/main" w="9525">
                   <a:solidFill>
                     <a:srgbClr val="000000"/>
                   </a:solidFill>
@@ -7751,7 +7985,7 @@
             </a:ln>
             <a:extLst>
               <a:ext uri="{91240B29-F687-4f45-9708-019B960494DF}">
-                <a14:hiddenLine xmlns:a14="http://schemas.microsoft.com/office/drawing/2010/main" xmlns="" w="9525">
+                <a14:hiddenLine xmlns="" xmlns:a14="http://schemas.microsoft.com/office/drawing/2010/main" w="9525">
                   <a:solidFill>
                     <a:srgbClr val="000000"/>
                   </a:solidFill>
@@ -7841,7 +8075,7 @@
             </a:ln>
             <a:extLst>
               <a:ext uri="{91240B29-F687-4f45-9708-019B960494DF}">
-                <a14:hiddenLine xmlns:a14="http://schemas.microsoft.com/office/drawing/2010/main" xmlns="" w="9525">
+                <a14:hiddenLine xmlns="" xmlns:a14="http://schemas.microsoft.com/office/drawing/2010/main" w="9525">
                   <a:solidFill>
                     <a:srgbClr val="000000"/>
                   </a:solidFill>
@@ -7931,7 +8165,7 @@
             </a:ln>
             <a:extLst>
               <a:ext uri="{91240B29-F687-4f45-9708-019B960494DF}">
-                <a14:hiddenLine xmlns:a14="http://schemas.microsoft.com/office/drawing/2010/main" xmlns="" w="9525">
+                <a14:hiddenLine xmlns="" xmlns:a14="http://schemas.microsoft.com/office/drawing/2010/main" w="9525">
                   <a:solidFill>
                     <a:srgbClr val="000000"/>
                   </a:solidFill>
@@ -7993,7 +8227,7 @@
             </a:ln>
             <a:extLst>
               <a:ext uri="{91240B29-F687-4f45-9708-019B960494DF}">
-                <a14:hiddenLine xmlns:a14="http://schemas.microsoft.com/office/drawing/2010/main" xmlns="" w="9525">
+                <a14:hiddenLine xmlns="" xmlns:a14="http://schemas.microsoft.com/office/drawing/2010/main" w="9525">
                   <a:solidFill>
                     <a:srgbClr val="000000"/>
                   </a:solidFill>
@@ -8113,7 +8347,7 @@
             </a:ln>
             <a:extLst>
               <a:ext uri="{91240B29-F687-4f45-9708-019B960494DF}">
-                <a14:hiddenLine xmlns:a14="http://schemas.microsoft.com/office/drawing/2010/main" xmlns="" w="9525">
+                <a14:hiddenLine xmlns="" xmlns:a14="http://schemas.microsoft.com/office/drawing/2010/main" w="9525">
                   <a:solidFill>
                     <a:srgbClr val="000000"/>
                   </a:solidFill>
@@ -8181,7 +8415,7 @@
             </a:ln>
             <a:extLst>
               <a:ext uri="{91240B29-F687-4f45-9708-019B960494DF}">
-                <a14:hiddenLine xmlns:a14="http://schemas.microsoft.com/office/drawing/2010/main" xmlns="" w="9525">
+                <a14:hiddenLine xmlns="" xmlns:a14="http://schemas.microsoft.com/office/drawing/2010/main" w="9525">
                   <a:solidFill>
                     <a:srgbClr val="000000"/>
                   </a:solidFill>
@@ -8271,7 +8505,7 @@
             </a:ln>
             <a:extLst>
               <a:ext uri="{91240B29-F687-4f45-9708-019B960494DF}">
-                <a14:hiddenLine xmlns:a14="http://schemas.microsoft.com/office/drawing/2010/main" xmlns="" w="9525">
+                <a14:hiddenLine xmlns="" xmlns:a14="http://schemas.microsoft.com/office/drawing/2010/main" w="9525">
                   <a:solidFill>
                     <a:srgbClr val="000000"/>
                   </a:solidFill>
@@ -8411,7 +8645,7 @@
           <a:p>
             <a:fld id="{48A87A34-81AB-432B-8DAE-1953F412C126}" type="datetimeFigureOut">
               <a:rPr lang="en-US" dirty="0"/>
-              <a:t>4/15/2026</a:t>
+              <a:t>4/20/2026</a:t>
             </a:fld>
             <a:endParaRPr lang="en-US" dirty="0"/>
           </a:p>
@@ -8673,7 +8907,7 @@
           <a:p>
             <a:fld id="{48A87A34-81AB-432B-8DAE-1953F412C126}" type="datetimeFigureOut">
               <a:rPr lang="en-US" dirty="0"/>
-              <a:t>4/15/2026</a:t>
+              <a:t>4/20/2026</a:t>
             </a:fld>
             <a:endParaRPr lang="en-US" dirty="0"/>
           </a:p>
@@ -8864,7 +9098,7 @@
           <a:p>
             <a:fld id="{48A87A34-81AB-432B-8DAE-1953F412C126}" type="datetimeFigureOut">
               <a:rPr lang="en-US" dirty="0"/>
-              <a:t>4/15/2026</a:t>
+              <a:t>4/20/2026</a:t>
             </a:fld>
             <a:endParaRPr lang="en-US" dirty="0"/>
           </a:p>
@@ -9122,7 +9356,7 @@
           <a:p>
             <a:fld id="{48A87A34-81AB-432B-8DAE-1953F412C126}" type="datetimeFigureOut">
               <a:rPr lang="en-US" dirty="0"/>
-              <a:t>4/15/2026</a:t>
+              <a:t>4/20/2026</a:t>
             </a:fld>
             <a:endParaRPr lang="en-US" dirty="0"/>
           </a:p>
@@ -9551,7 +9785,7 @@
           <a:p>
             <a:fld id="{48A87A34-81AB-432B-8DAE-1953F412C126}" type="datetimeFigureOut">
               <a:rPr lang="en-US" dirty="0"/>
-              <a:t>4/15/2026</a:t>
+              <a:t>4/20/2026</a:t>
             </a:fld>
             <a:endParaRPr lang="en-US" dirty="0"/>
           </a:p>
@@ -10092,7 +10326,7 @@
           <a:p>
             <a:fld id="{48A87A34-81AB-432B-8DAE-1953F412C126}" type="datetimeFigureOut">
               <a:rPr lang="en-US" dirty="0"/>
-              <a:t>4/15/2026</a:t>
+              <a:t>4/20/2026</a:t>
             </a:fld>
             <a:endParaRPr lang="en-US" dirty="0"/>
           </a:p>
@@ -10807,7 +11041,7 @@
           <a:p>
             <a:fld id="{48A87A34-81AB-432B-8DAE-1953F412C126}" type="datetimeFigureOut">
               <a:rPr lang="en-US" dirty="0"/>
-              <a:t>4/15/2026</a:t>
+              <a:t>4/20/2026</a:t>
             </a:fld>
             <a:endParaRPr lang="en-US" dirty="0"/>
           </a:p>
@@ -10972,7 +11206,7 @@
           <a:p>
             <a:fld id="{48A87A34-81AB-432B-8DAE-1953F412C126}" type="datetimeFigureOut">
               <a:rPr lang="en-US" dirty="0"/>
-              <a:t>4/15/2026</a:t>
+              <a:t>4/20/2026</a:t>
             </a:fld>
             <a:endParaRPr lang="en-US" dirty="0"/>
           </a:p>
@@ -11147,7 +11381,7 @@
           <a:p>
             <a:fld id="{48A87A34-81AB-432B-8DAE-1953F412C126}" type="datetimeFigureOut">
               <a:rPr lang="en-US" dirty="0"/>
-              <a:t>4/15/2026</a:t>
+              <a:t>4/20/2026</a:t>
             </a:fld>
             <a:endParaRPr lang="en-US" dirty="0"/>
           </a:p>
@@ -11312,7 +11546,7 @@
           <a:p>
             <a:fld id="{48A87A34-81AB-432B-8DAE-1953F412C126}" type="datetimeFigureOut">
               <a:rPr lang="en-US" dirty="0"/>
-              <a:t>4/15/2026</a:t>
+              <a:t>4/20/2026</a:t>
             </a:fld>
             <a:endParaRPr lang="en-US" dirty="0"/>
           </a:p>
@@ -11557,7 +11791,7 @@
           <a:p>
             <a:fld id="{48A87A34-81AB-432B-8DAE-1953F412C126}" type="datetimeFigureOut">
               <a:rPr lang="en-US" dirty="0"/>
-              <a:t>4/15/2026</a:t>
+              <a:t>4/20/2026</a:t>
             </a:fld>
             <a:endParaRPr lang="en-US" dirty="0"/>
           </a:p>
@@ -11784,7 +12018,7 @@
           <a:p>
             <a:fld id="{48A87A34-81AB-432B-8DAE-1953F412C126}" type="datetimeFigureOut">
               <a:rPr lang="en-US" dirty="0"/>
-              <a:t>4/15/2026</a:t>
+              <a:t>4/20/2026</a:t>
             </a:fld>
             <a:endParaRPr lang="en-US" dirty="0"/>
           </a:p>
@@ -12160,7 +12394,7 @@
           <a:p>
             <a:fld id="{48A87A34-81AB-432B-8DAE-1953F412C126}" type="datetimeFigureOut">
               <a:rPr lang="en-US" dirty="0"/>
-              <a:t>4/15/2026</a:t>
+              <a:t>4/20/2026</a:t>
             </a:fld>
             <a:endParaRPr lang="en-US" dirty="0"/>
           </a:p>
@@ -12273,7 +12507,7 @@
           <a:p>
             <a:fld id="{48A87A34-81AB-432B-8DAE-1953F412C126}" type="datetimeFigureOut">
               <a:rPr lang="en-US" dirty="0"/>
-              <a:t>4/15/2026</a:t>
+              <a:t>4/20/2026</a:t>
             </a:fld>
             <a:endParaRPr lang="en-US" dirty="0"/>
           </a:p>
@@ -12363,7 +12597,7 @@
           <a:p>
             <a:fld id="{48A87A34-81AB-432B-8DAE-1953F412C126}" type="datetimeFigureOut">
               <a:rPr lang="en-US" dirty="0"/>
-              <a:t>4/15/2026</a:t>
+              <a:t>4/20/2026</a:t>
             </a:fld>
             <a:endParaRPr lang="en-US" dirty="0"/>
           </a:p>
@@ -12607,7 +12841,7 @@
           <a:p>
             <a:fld id="{48A87A34-81AB-432B-8DAE-1953F412C126}" type="datetimeFigureOut">
               <a:rPr lang="en-US" dirty="0"/>
-              <a:t>4/15/2026</a:t>
+              <a:t>4/20/2026</a:t>
             </a:fld>
             <a:endParaRPr lang="en-US" dirty="0"/>
           </a:p>
@@ -12882,7 +13116,7 @@
           <a:p>
             <a:fld id="{48A87A34-81AB-432B-8DAE-1953F412C126}" type="datetimeFigureOut">
               <a:rPr lang="en-US" dirty="0"/>
-              <a:t>4/15/2026</a:t>
+              <a:t>4/20/2026</a:t>
             </a:fld>
             <a:endParaRPr lang="en-US" dirty="0"/>
           </a:p>
@@ -12993,7 +13227,7 @@
           <a:noFill/>
           <a:extLst>
             <a:ext uri="{909E8E84-426E-40dd-AFC4-6F175D3DCCD1}">
-              <a14:hiddenFill xmlns:a14="http://schemas.microsoft.com/office/drawing/2010/main" xmlns="">
+              <a14:hiddenFill xmlns="" xmlns:a14="http://schemas.microsoft.com/office/drawing/2010/main">
                 <a:solidFill>
                   <a:srgbClr val="FFFFFF"/>
                 </a:solidFill>
@@ -13067,7 +13301,7 @@
               </a:ln>
               <a:extLst>
                 <a:ext uri="{91240B29-F687-4f45-9708-019B960494DF}">
-                  <a14:hiddenLine xmlns:a14="http://schemas.microsoft.com/office/drawing/2010/main" xmlns="" w="9525">
+                  <a14:hiddenLine xmlns="" xmlns:a14="http://schemas.microsoft.com/office/drawing/2010/main" w="9525">
                     <a:solidFill>
                       <a:srgbClr val="000000"/>
                     </a:solidFill>
@@ -13157,7 +13391,7 @@
               </a:ln>
               <a:extLst>
                 <a:ext uri="{91240B29-F687-4f45-9708-019B960494DF}">
-                  <a14:hiddenLine xmlns:a14="http://schemas.microsoft.com/office/drawing/2010/main" xmlns="" w="9525">
+                  <a14:hiddenLine xmlns="" xmlns:a14="http://schemas.microsoft.com/office/drawing/2010/main" w="9525">
                     <a:solidFill>
                       <a:srgbClr val="000000"/>
                     </a:solidFill>
@@ -13247,7 +13481,7 @@
               </a:ln>
               <a:extLst>
                 <a:ext uri="{91240B29-F687-4f45-9708-019B960494DF}">
-                  <a14:hiddenLine xmlns:a14="http://schemas.microsoft.com/office/drawing/2010/main" xmlns="" w="9525">
+                  <a14:hiddenLine xmlns="" xmlns:a14="http://schemas.microsoft.com/office/drawing/2010/main" w="9525">
                     <a:solidFill>
                       <a:srgbClr val="000000"/>
                     </a:solidFill>
@@ -13309,7 +13543,7 @@
               </a:ln>
               <a:extLst>
                 <a:ext uri="{91240B29-F687-4f45-9708-019B960494DF}">
-                  <a14:hiddenLine xmlns:a14="http://schemas.microsoft.com/office/drawing/2010/main" xmlns="" w="9525">
+                  <a14:hiddenLine xmlns="" xmlns:a14="http://schemas.microsoft.com/office/drawing/2010/main" w="9525">
                     <a:solidFill>
                       <a:srgbClr val="000000"/>
                     </a:solidFill>
@@ -13399,7 +13633,7 @@
               </a:ln>
               <a:extLst>
                 <a:ext uri="{91240B29-F687-4f45-9708-019B960494DF}">
-                  <a14:hiddenLine xmlns:a14="http://schemas.microsoft.com/office/drawing/2010/main" xmlns="" w="9525">
+                  <a14:hiddenLine xmlns="" xmlns:a14="http://schemas.microsoft.com/office/drawing/2010/main" w="9525">
                     <a:solidFill>
                       <a:srgbClr val="000000"/>
                     </a:solidFill>
@@ -13461,7 +13695,7 @@
               </a:ln>
               <a:extLst>
                 <a:ext uri="{91240B29-F687-4f45-9708-019B960494DF}">
-                  <a14:hiddenLine xmlns:a14="http://schemas.microsoft.com/office/drawing/2010/main" xmlns="" w="9525">
+                  <a14:hiddenLine xmlns="" xmlns:a14="http://schemas.microsoft.com/office/drawing/2010/main" w="9525">
                     <a:solidFill>
                       <a:srgbClr val="000000"/>
                     </a:solidFill>
@@ -13523,7 +13757,7 @@
               </a:ln>
               <a:extLst>
                 <a:ext uri="{91240B29-F687-4f45-9708-019B960494DF}">
-                  <a14:hiddenLine xmlns:a14="http://schemas.microsoft.com/office/drawing/2010/main" xmlns="" w="9525">
+                  <a14:hiddenLine xmlns="" xmlns:a14="http://schemas.microsoft.com/office/drawing/2010/main" w="9525">
                     <a:solidFill>
                       <a:srgbClr val="000000"/>
                     </a:solidFill>
@@ -13613,7 +13847,7 @@
               </a:ln>
               <a:extLst>
                 <a:ext uri="{91240B29-F687-4f45-9708-019B960494DF}">
-                  <a14:hiddenLine xmlns:a14="http://schemas.microsoft.com/office/drawing/2010/main" xmlns="" w="9525">
+                  <a14:hiddenLine xmlns="" xmlns:a14="http://schemas.microsoft.com/office/drawing/2010/main" w="9525">
                     <a:solidFill>
                       <a:srgbClr val="000000"/>
                     </a:solidFill>
@@ -13703,7 +13937,7 @@
               </a:ln>
               <a:extLst>
                 <a:ext uri="{91240B29-F687-4f45-9708-019B960494DF}">
-                  <a14:hiddenLine xmlns:a14="http://schemas.microsoft.com/office/drawing/2010/main" xmlns="" w="9525">
+                  <a14:hiddenLine xmlns="" xmlns:a14="http://schemas.microsoft.com/office/drawing/2010/main" w="9525">
                     <a:solidFill>
                       <a:srgbClr val="000000"/>
                     </a:solidFill>
@@ -13765,7 +13999,7 @@
               </a:ln>
               <a:extLst>
                 <a:ext uri="{91240B29-F687-4f45-9708-019B960494DF}">
-                  <a14:hiddenLine xmlns:a14="http://schemas.microsoft.com/office/drawing/2010/main" xmlns="" w="9525">
+                  <a14:hiddenLine xmlns="" xmlns:a14="http://schemas.microsoft.com/office/drawing/2010/main" w="9525">
                     <a:solidFill>
                       <a:srgbClr val="000000"/>
                     </a:solidFill>
@@ -13875,7 +14109,7 @@
               </a:ln>
               <a:extLst>
                 <a:ext uri="{91240B29-F687-4f45-9708-019B960494DF}">
-                  <a14:hiddenLine xmlns:a14="http://schemas.microsoft.com/office/drawing/2010/main" xmlns="" w="9525">
+                  <a14:hiddenLine xmlns="" xmlns:a14="http://schemas.microsoft.com/office/drawing/2010/main" w="9525">
                     <a:solidFill>
                       <a:srgbClr val="000000"/>
                     </a:solidFill>
@@ -13959,7 +14193,7 @@
               </a:ln>
               <a:extLst>
                 <a:ext uri="{91240B29-F687-4f45-9708-019B960494DF}">
-                  <a14:hiddenLine xmlns:a14="http://schemas.microsoft.com/office/drawing/2010/main" xmlns="" w="9525">
+                  <a14:hiddenLine xmlns="" xmlns:a14="http://schemas.microsoft.com/office/drawing/2010/main" w="9525">
                     <a:solidFill>
                       <a:srgbClr val="000000"/>
                     </a:solidFill>
@@ -14021,7 +14255,7 @@
               </a:ln>
               <a:extLst>
                 <a:ext uri="{91240B29-F687-4f45-9708-019B960494DF}">
-                  <a14:hiddenLine xmlns:a14="http://schemas.microsoft.com/office/drawing/2010/main" xmlns="" w="9525">
+                  <a14:hiddenLine xmlns="" xmlns:a14="http://schemas.microsoft.com/office/drawing/2010/main" w="9525">
                     <a:solidFill>
                       <a:srgbClr val="000000"/>
                     </a:solidFill>
@@ -14083,7 +14317,7 @@
               </a:ln>
               <a:extLst>
                 <a:ext uri="{91240B29-F687-4f45-9708-019B960494DF}">
-                  <a14:hiddenLine xmlns:a14="http://schemas.microsoft.com/office/drawing/2010/main" xmlns="" w="9525">
+                  <a14:hiddenLine xmlns="" xmlns:a14="http://schemas.microsoft.com/office/drawing/2010/main" w="9525">
                     <a:solidFill>
                       <a:srgbClr val="000000"/>
                     </a:solidFill>
@@ -14173,7 +14407,7 @@
               </a:ln>
               <a:extLst>
                 <a:ext uri="{91240B29-F687-4f45-9708-019B960494DF}">
-                  <a14:hiddenLine xmlns:a14="http://schemas.microsoft.com/office/drawing/2010/main" xmlns="" w="9525">
+                  <a14:hiddenLine xmlns="" xmlns:a14="http://schemas.microsoft.com/office/drawing/2010/main" w="9525">
                     <a:solidFill>
                       <a:srgbClr val="000000"/>
                     </a:solidFill>
@@ -14207,7 +14441,7 @@
               </a:ln>
               <a:extLst>
                 <a:ext uri="{91240B29-F687-4f45-9708-019B960494DF}">
-                  <a14:hiddenLine xmlns:a14="http://schemas.microsoft.com/office/drawing/2010/main" xmlns="" w="9525">
+                  <a14:hiddenLine xmlns="" xmlns:a14="http://schemas.microsoft.com/office/drawing/2010/main" w="9525">
                     <a:solidFill>
                       <a:srgbClr val="000000"/>
                     </a:solidFill>
@@ -14272,7 +14506,7 @@
               </a:ln>
               <a:extLst>
                 <a:ext uri="{91240B29-F687-4f45-9708-019B960494DF}">
-                  <a14:hiddenLine xmlns:a14="http://schemas.microsoft.com/office/drawing/2010/main" xmlns="" w="9525">
+                  <a14:hiddenLine xmlns="" xmlns:a14="http://schemas.microsoft.com/office/drawing/2010/main" w="9525">
                     <a:solidFill>
                       <a:srgbClr val="000000"/>
                     </a:solidFill>
@@ -14362,7 +14596,7 @@
               </a:ln>
               <a:extLst>
                 <a:ext uri="{91240B29-F687-4f45-9708-019B960494DF}">
-                  <a14:hiddenLine xmlns:a14="http://schemas.microsoft.com/office/drawing/2010/main" xmlns="" w="9525">
+                  <a14:hiddenLine xmlns="" xmlns:a14="http://schemas.microsoft.com/office/drawing/2010/main" w="9525">
                     <a:solidFill>
                       <a:srgbClr val="000000"/>
                     </a:solidFill>
@@ -14424,7 +14658,7 @@
               </a:ln>
               <a:extLst>
                 <a:ext uri="{91240B29-F687-4f45-9708-019B960494DF}">
-                  <a14:hiddenLine xmlns:a14="http://schemas.microsoft.com/office/drawing/2010/main" xmlns="" w="9525">
+                  <a14:hiddenLine xmlns="" xmlns:a14="http://schemas.microsoft.com/office/drawing/2010/main" w="9525">
                     <a:solidFill>
                       <a:srgbClr val="000000"/>
                     </a:solidFill>
@@ -14514,7 +14748,7 @@
               </a:ln>
               <a:extLst>
                 <a:ext uri="{91240B29-F687-4f45-9708-019B960494DF}">
-                  <a14:hiddenLine xmlns:a14="http://schemas.microsoft.com/office/drawing/2010/main" xmlns="" w="9525">
+                  <a14:hiddenLine xmlns="" xmlns:a14="http://schemas.microsoft.com/office/drawing/2010/main" w="9525">
                     <a:solidFill>
                       <a:srgbClr val="000000"/>
                     </a:solidFill>
@@ -14579,7 +14813,7 @@
               </a:ln>
               <a:extLst>
                 <a:ext uri="{91240B29-F687-4f45-9708-019B960494DF}">
-                  <a14:hiddenLine xmlns:a14="http://schemas.microsoft.com/office/drawing/2010/main" xmlns="" w="9525">
+                  <a14:hiddenLine xmlns="" xmlns:a14="http://schemas.microsoft.com/office/drawing/2010/main" w="9525">
                     <a:solidFill>
                       <a:srgbClr val="000000"/>
                     </a:solidFill>
@@ -14641,7 +14875,7 @@
               </a:ln>
               <a:extLst>
                 <a:ext uri="{91240B29-F687-4f45-9708-019B960494DF}">
-                  <a14:hiddenLine xmlns:a14="http://schemas.microsoft.com/office/drawing/2010/main" xmlns="" w="9525">
+                  <a14:hiddenLine xmlns="" xmlns:a14="http://schemas.microsoft.com/office/drawing/2010/main" w="9525">
                     <a:solidFill>
                       <a:srgbClr val="000000"/>
                     </a:solidFill>
@@ -14731,7 +14965,7 @@
               </a:ln>
               <a:extLst>
                 <a:ext uri="{91240B29-F687-4f45-9708-019B960494DF}">
-                  <a14:hiddenLine xmlns:a14="http://schemas.microsoft.com/office/drawing/2010/main" xmlns="" w="9525">
+                  <a14:hiddenLine xmlns="" xmlns:a14="http://schemas.microsoft.com/office/drawing/2010/main" w="9525">
                     <a:solidFill>
                       <a:srgbClr val="000000"/>
                     </a:solidFill>
@@ -14821,7 +15055,7 @@
               </a:ln>
               <a:extLst>
                 <a:ext uri="{91240B29-F687-4f45-9708-019B960494DF}">
-                  <a14:hiddenLine xmlns:a14="http://schemas.microsoft.com/office/drawing/2010/main" xmlns="" w="9525">
+                  <a14:hiddenLine xmlns="" xmlns:a14="http://schemas.microsoft.com/office/drawing/2010/main" w="9525">
                     <a:solidFill>
                       <a:srgbClr val="000000"/>
                     </a:solidFill>
@@ -14886,7 +15120,7 @@
               </a:ln>
               <a:extLst>
                 <a:ext uri="{91240B29-F687-4f45-9708-019B960494DF}">
-                  <a14:hiddenLine xmlns:a14="http://schemas.microsoft.com/office/drawing/2010/main" xmlns="" w="9525">
+                  <a14:hiddenLine xmlns="" xmlns:a14="http://schemas.microsoft.com/office/drawing/2010/main" w="9525">
                     <a:solidFill>
                       <a:srgbClr val="000000"/>
                     </a:solidFill>
@@ -15006,7 +15240,7 @@
               </a:ln>
               <a:extLst>
                 <a:ext uri="{91240B29-F687-4f45-9708-019B960494DF}">
-                  <a14:hiddenLine xmlns:a14="http://schemas.microsoft.com/office/drawing/2010/main" xmlns="" w="9525">
+                  <a14:hiddenLine xmlns="" xmlns:a14="http://schemas.microsoft.com/office/drawing/2010/main" w="9525">
                     <a:solidFill>
                       <a:srgbClr val="000000"/>
                     </a:solidFill>
@@ -15104,7 +15338,7 @@
               </a:ln>
               <a:extLst>
                 <a:ext uri="{91240B29-F687-4f45-9708-019B960494DF}">
-                  <a14:hiddenLine xmlns:a14="http://schemas.microsoft.com/office/drawing/2010/main" xmlns="" w="9525">
+                  <a14:hiddenLine xmlns="" xmlns:a14="http://schemas.microsoft.com/office/drawing/2010/main" w="9525">
                     <a:solidFill>
                       <a:srgbClr val="000000"/>
                     </a:solidFill>
@@ -15219,7 +15453,7 @@
               </a:ln>
               <a:extLst>
                 <a:ext uri="{91240B29-F687-4f45-9708-019B960494DF}">
-                  <a14:hiddenLine xmlns:a14="http://schemas.microsoft.com/office/drawing/2010/main" xmlns="" w="9525">
+                  <a14:hiddenLine xmlns="" xmlns:a14="http://schemas.microsoft.com/office/drawing/2010/main" w="9525">
                     <a:solidFill>
                       <a:srgbClr val="000000"/>
                     </a:solidFill>
@@ -15309,7 +15543,7 @@
               </a:ln>
               <a:extLst>
                 <a:ext uri="{91240B29-F687-4f45-9708-019B960494DF}">
-                  <a14:hiddenLine xmlns:a14="http://schemas.microsoft.com/office/drawing/2010/main" xmlns="" w="9525">
+                  <a14:hiddenLine xmlns="" xmlns:a14="http://schemas.microsoft.com/office/drawing/2010/main" w="9525">
                     <a:solidFill>
                       <a:srgbClr val="000000"/>
                     </a:solidFill>
@@ -15374,7 +15608,7 @@
               </a:ln>
               <a:extLst>
                 <a:ext uri="{91240B29-F687-4f45-9708-019B960494DF}">
-                  <a14:hiddenLine xmlns:a14="http://schemas.microsoft.com/office/drawing/2010/main" xmlns="" w="9525">
+                  <a14:hiddenLine xmlns="" xmlns:a14="http://schemas.microsoft.com/office/drawing/2010/main" w="9525">
                     <a:solidFill>
                       <a:srgbClr val="000000"/>
                     </a:solidFill>
@@ -15464,7 +15698,7 @@
               </a:ln>
               <a:extLst>
                 <a:ext uri="{91240B29-F687-4f45-9708-019B960494DF}">
-                  <a14:hiddenLine xmlns:a14="http://schemas.microsoft.com/office/drawing/2010/main" xmlns="" w="9525">
+                  <a14:hiddenLine xmlns="" xmlns:a14="http://schemas.microsoft.com/office/drawing/2010/main" w="9525">
                     <a:solidFill>
                       <a:srgbClr val="000000"/>
                     </a:solidFill>
@@ -15532,7 +15766,7 @@
               </a:ln>
               <a:extLst>
                 <a:ext uri="{91240B29-F687-4f45-9708-019B960494DF}">
-                  <a14:hiddenLine xmlns:a14="http://schemas.microsoft.com/office/drawing/2010/main" xmlns="" w="9525">
+                  <a14:hiddenLine xmlns="" xmlns:a14="http://schemas.microsoft.com/office/drawing/2010/main" w="9525">
                     <a:solidFill>
                       <a:srgbClr val="000000"/>
                     </a:solidFill>
@@ -15622,7 +15856,7 @@
               </a:ln>
               <a:extLst>
                 <a:ext uri="{91240B29-F687-4f45-9708-019B960494DF}">
-                  <a14:hiddenLine xmlns:a14="http://schemas.microsoft.com/office/drawing/2010/main" xmlns="" w="9525">
+                  <a14:hiddenLine xmlns="" xmlns:a14="http://schemas.microsoft.com/office/drawing/2010/main" w="9525">
                     <a:solidFill>
                       <a:srgbClr val="000000"/>
                     </a:solidFill>
@@ -15690,7 +15924,7 @@
               </a:ln>
               <a:extLst>
                 <a:ext uri="{91240B29-F687-4f45-9708-019B960494DF}">
-                  <a14:hiddenLine xmlns:a14="http://schemas.microsoft.com/office/drawing/2010/main" xmlns="" w="9525">
+                  <a14:hiddenLine xmlns="" xmlns:a14="http://schemas.microsoft.com/office/drawing/2010/main" w="9525">
                     <a:solidFill>
                       <a:srgbClr val="000000"/>
                     </a:solidFill>
@@ -15780,7 +16014,7 @@
               </a:ln>
               <a:extLst>
                 <a:ext uri="{91240B29-F687-4f45-9708-019B960494DF}">
-                  <a14:hiddenLine xmlns:a14="http://schemas.microsoft.com/office/drawing/2010/main" xmlns="" w="9525">
+                  <a14:hiddenLine xmlns="" xmlns:a14="http://schemas.microsoft.com/office/drawing/2010/main" w="9525">
                     <a:solidFill>
                       <a:srgbClr val="000000"/>
                     </a:solidFill>
@@ -15814,7 +16048,7 @@
               </a:ln>
               <a:extLst>
                 <a:ext uri="{91240B29-F687-4f45-9708-019B960494DF}">
-                  <a14:hiddenLine xmlns:a14="http://schemas.microsoft.com/office/drawing/2010/main" xmlns="" w="9525">
+                  <a14:hiddenLine xmlns="" xmlns:a14="http://schemas.microsoft.com/office/drawing/2010/main" w="9525">
                     <a:solidFill>
                       <a:srgbClr val="000000"/>
                     </a:solidFill>
@@ -15955,7 +16189,7 @@
             <a:fld id="{48A87A34-81AB-432B-8DAE-1953F412C126}" type="datetimeFigureOut">
               <a:rPr lang="en-US" dirty="0"/>
               <a:pPr/>
-              <a:t>4/15/2026</a:t>
+              <a:t>4/20/2026</a:t>
             </a:fld>
             <a:endParaRPr lang="en-US" dirty="0"/>
           </a:p>
@@ -17078,7 +17312,7 @@
                 <a:latin typeface="Segoe UI" panose="020B0502040204020203" pitchFamily="34" charset="0"/>
                 <a:cs typeface="Segoe UI" panose="020B0502040204020203" pitchFamily="34" charset="0"/>
               </a:rPr>
-              <a:t>Progression cohérente du SQL au LLM en production</a:t>
+              <a:t>La progression cohérente du SQL au LLM en production</a:t>
             </a:r>
           </a:p>
           <a:p>
@@ -17097,7 +17331,7 @@
                 <a:latin typeface="Segoe UI" panose="020B0502040204020203" pitchFamily="34" charset="0"/>
                 <a:cs typeface="Segoe UI" panose="020B0502040204020203" pitchFamily="34" charset="0"/>
               </a:rPr>
-              <a:t>Capacité à travailler sur toute la chaîne data </a:t>
+              <a:t>La capacité à travailler sur toute la chaîne data </a:t>
             </a:r>
             <a:r>
               <a:rPr lang="fr-FR" sz="1200" i="1" dirty="0">
@@ -17127,7 +17361,7 @@
                 <a:latin typeface="Segoe UI" panose="020B0502040204020203" pitchFamily="34" charset="0"/>
                 <a:cs typeface="Segoe UI" panose="020B0502040204020203" pitchFamily="34" charset="0"/>
               </a:rPr>
-              <a:t>Projets réels sur des problématiques métier concrètes</a:t>
+              <a:t>La mise en œuvre de projets réels sur des problématiques métier concrètes</a:t>
             </a:r>
             <a:endParaRPr lang="fr-FR" sz="1100" dirty="0">
               <a:latin typeface="Segoe UI" panose="020B0502040204020203" pitchFamily="34" charset="0"/>

</xml_diff>